<commit_message>
docs(presentation): lighter methods slide, architectures in a backup, measured timing guidance
</commit_message>
<xml_diff>
--- a/docs/presentation/NALTRA_final.pptx
+++ b/docs/presentation/NALTRA_final.pptx
@@ -15,6 +15,7 @@
     <p:sldId xmlns:r="http://schemas.openxmlformats.org/officeDocument/2006/relationships" id="260" r:id="Re779c1b189ee42bf"/>
     <p:sldId xmlns:ns0="http://schemas.openxmlformats.org/officeDocument/2006/relationships" id="261" ns0:id="rId11"/>
     <p:sldId xmlns:ns0="http://schemas.openxmlformats.org/officeDocument/2006/relationships" id="262" ns0:id="rId12"/>
+    <p:sldId xmlns:ns0="http://schemas.openxmlformats.org/officeDocument/2006/relationships" id="263" ns0:id="rId13"/>
   </p:sldIdLst>
   <p:sldSz cx="12192000" cy="6858000"/>
   <p:notesSz cx="6858000" cy="9144000"/>
@@ -448,17 +449,17 @@
           <a:lstStyle xmlns:a="http://schemas.openxmlformats.org/drawingml/2006/main"/>
           <a:p xmlns:a="http://schemas.openxmlformats.org/drawingml/2006/main">
             <a:r>
-              <a:t>0:00–0:23</a:t>
+              <a:t>0:00–0:20</a:t>
             </a:r>
           </a:p>
           <a:p xmlns:a="http://schemas.openxmlformats.org/drawingml/2006/main">
             <a:r>
-              <a:t>Routing research projects by field should work when the text is Turkish or mixed. NALTRA predicts not one topic but all of a project's fields and their ancestors. We built a new paired benchmark in English and machine-translated Turkish, and test flagging projects from a held-out field.</a:t>
+              <a:t>Routing research projects by field should work for Turkish or mixed text. NALTRA predicts all of a project's fields and their ancestors, not one topic. We built a new paired benchmark in English and machine-translated Turkish, and test flagging projects from a held-out field.</a:t>
             </a:r>
           </a:p>
           <a:p xmlns:a="http://schemas.openxmlformats.org/drawingml/2006/main">
             <a:r>
-              <a:t>Sources (not spoken): README.md (task, 3.2 labels per project); docs/dataset.md (code-switch and noisy tracks); data/processed/cordis_h2020/code_switch/sentence_mix/balanced/test.jsonl, project 895187 (gold labels laser_physics, particle_physics and their ancestors).</a:t>
+              <a:t>Sources (not spoken): README.md (task, 3.2 labels per project); docs/dataset.md (code-switch and noisy tracks); data/processed/cordis_h2020/code_switch/sentence_mix/balanced/test.jsonl, project 895187 (gold labels laser_physics, particle_physics and their ancestors). Held-out field: humanities, a retained-label holdout (README.md research question 3; docs/evaluation.md#ood-and-efficiency).</a:t>
             </a:r>
           </a:p>
         </p:txBody>
@@ -528,17 +529,17 @@
           <a:lstStyle xmlns:a="http://schemas.openxmlformats.org/drawingml/2006/main"/>
           <a:p xmlns:a="http://schemas.openxmlformats.org/drawingml/2006/main">
             <a:r>
-              <a:t>0:23–0:36</a:t>
+              <a:t>0:22–0:33</a:t>
             </a:r>
           </a:p>
           <a:p xmlns:a="http://schemas.openxmlformats.org/drawingml/2006/main">
             <a:r>
-              <a:t>From CORDIS we kept about thirty-one thousand EU projects and four hundred seventy-three fields; code-switched and noisy test copies share one project-level split.</a:t>
+              <a:t>From CORDIS we kept about thirty-one thousand EU projects and four hundred seventy-three fields; code-switched and noisy copies share one project-level split.</a:t>
             </a:r>
           </a:p>
           <a:p xmlns:a="http://schemas.openxmlformats.org/drawingml/2006/main">
             <a:r>
-              <a:t>Sources (not spoken): docs/dataset.md: 283,002 aligned sentence pairs (section 8), 18,844 code-switched records (section 9), label support of 50 or more, grouped project split.</a:t>
+              <a:t>Sources (not spoken): data/README.md#at-a-glance (283,002 aligned sentence pairs; 9,422 records in each of the two code-switch tracks = 18,844); docs/dataset.md#translation, #derived-evaluation-tracks (code-switch and noisy copies) and #labels-and-splits (label support of 50 or more, grouped project split).</a:t>
             </a:r>
           </a:p>
         </p:txBody>
@@ -608,17 +609,17 @@
           <a:lstStyle xmlns:a="http://schemas.openxmlformats.org/drawingml/2006/main"/>
           <a:p xmlns:a="http://schemas.openxmlformats.org/drawingml/2006/main">
             <a:r>
-              <a:t>0:36–0:54</a:t>
+              <a:t>0:35–0:55</a:t>
             </a:r>
           </a:p>
           <a:p xmlns:a="http://schemas.openxmlformats.org/drawingml/2006/main">
             <a:r>
-              <a:t>Course baselines: Naive Bayes, SVM, BiLSTM and XLM-R. Our new methods: a sparse-plus-dense kNN, voting ensembles, and zero-shot Kev, Jev and Laya. We rank by micro-F1, since predicting no label scores ninety-nine percent accuracy.</a:t>
+              <a:t>Course baselines: Naive Bayes, SVM, BiLSTM and XLM-R. New methods: hybrid kNN, NALTRA votes and zero-shot Kev, Jev and Laya. We rank by micro-F1, since predicting no label scores ninety-nine percent accuracy.</a:t>
             </a:r>
           </a:p>
           <a:p xmlns:a="http://schemas.openxmlformats.org/drawingml/2006/main">
             <a:r>
-              <a:t>Sources (not spoken): README.md Models table and configs/models/*.yaml (architecture vs model); results/metrics/cordis_v1.1.0_ensemble/summary.json members (votes over svm, hybrid_knn, bilstm, transformer; the sample adds kev and jev) and label_distribution all_negative_accuracy 0.9932.</a:t>
+              <a:t>Sources (not spoken): README.md Models table and configs/models/*.yaml (architecture vs model, hidden backup B3); results/metrics/cordis_v1.1.0_ensemble/summary.json members (votes over svm, hybrid_knn, bilstm, transformer; the sample adds kev and jev) and label_distribution all_negative_accuracy 0.9932.</a:t>
             </a:r>
           </a:p>
         </p:txBody>
@@ -688,12 +689,12 @@
           <a:lstStyle xmlns:a="http://schemas.openxmlformats.org/drawingml/2006/main"/>
           <a:p xmlns:a="http://schemas.openxmlformats.org/drawingml/2006/main">
             <a:r>
-              <a:t>0:54–1:19</a:t>
+              <a:t>0:57–1:15</a:t>
             </a:r>
           </a:p>
           <a:p xmlns:a="http://schemas.openxmlformats.org/drawingml/2006/main">
             <a:r>
-              <a:t>SVM wins every full test set: in English zero point five six, or zero point six seven hierarchical, in Turkish zero point four nine, in two milliseconds per text. No vote beats it. On a hundred-twenty-project sample, zero-shot Jev and Kev reach about zero point two seven, far below SVM.</a:t>
+              <a:t>SVM wins every full test set: English zero point five six, Turkish zero point four nine, at two milliseconds per text. No vote beats it. On a hundred-twenty-project sample, Jev and Kev reach about zero point two seven.</a:t>
             </a:r>
           </a:p>
           <a:p xmlns:a="http://schemas.openxmlformats.org/drawingml/2006/main">
@@ -768,12 +769,12 @@
           <a:lstStyle xmlns:a="http://schemas.openxmlformats.org/drawingml/2006/main"/>
           <a:p xmlns:a="http://schemas.openxmlformats.org/drawingml/2006/main">
             <a:r>
-              <a:t>1:19–1:47</a:t>
+              <a:t>1:17–1:49</a:t>
             </a:r>
           </a:p>
           <a:p xmlns:a="http://schemas.openxmlformats.org/drawingml/2006/main">
             <a:r>
-              <a:t>Robustness flips the picture: from English to Turkish SVM loses seven points, our kNN one, and on Turkish, code-switched and noisy English it loses significantly more than every other trained model. With humanities held out, a retrained SVM separates humanities-only projects at zero point nine three AUROC. Take-home: the highest micro-F1 is not the most robust.</a:t>
+              <a:t>Robustness flips: from English to Turkish SVM loses seven points, kNN one; on Turkish, code-switched and noisy English, SVM loses significantly more than every other trained model. A retrained SVM separates held-out humanities-only projects at zero point nine three AUROC. Limits: one seed, translated Turkish, silver labels. Take-home: the highest micro-F1 is not the most robust.</a:t>
             </a:r>
           </a:p>
           <a:p xmlns:a="http://schemas.openxmlformats.org/drawingml/2006/main">
@@ -944,6 +945,86 @@
           <a:p>
             <a:r>
               <a:t>Sources (not spoken): results/metrics/cordis_v1.1.0_sample/summary.json, pairwise.json; results/ood/cordis_v1.1.0/summary.json</a:t>
+            </a:r>
+          </a:p>
+        </p:txBody>
+      </p:sp>
+      <p:sp>
+        <p:nvSpPr>
+          <p:cNvPr id="4" name="Slide Number Placeholder 3"/>
+          <p:cNvSpPr>
+            <a:spLocks noGrp="1"/>
+          </p:cNvSpPr>
+          <p:nvPr>
+            <p:ph type="sldNum" idx="5" sz="quarter"/>
+          </p:nvPr>
+        </p:nvSpPr>
+        <p:spPr/>
+      </p:sp>
+    </p:spTree>
+  </p:cSld>
+  <p:clrMapOvr>
+    <a:masterClrMapping/>
+  </p:clrMapOvr>
+</p:notes>
+</file>
+
+<file path=ppt/notesSlides/notesSlide8.xml><?xml version="1.0" encoding="utf-8"?>
+<p:notes xmlns:a="http://schemas.openxmlformats.org/drawingml/2006/main" xmlns:p="http://schemas.openxmlformats.org/presentationml/2006/main" xmlns:r="http://schemas.openxmlformats.org/officeDocument/2006/relationships">
+  <p:cSld>
+    <p:spTree>
+      <p:nvGrpSpPr>
+        <p:cNvPr id="1" name=""/>
+        <p:cNvGrpSpPr/>
+        <p:nvPr/>
+      </p:nvGrpSpPr>
+      <p:grpSpPr>
+        <a:xfrm>
+          <a:off x="0" y="0"/>
+          <a:ext cx="0" cy="0"/>
+          <a:chOff x="0" y="0"/>
+          <a:chExt cx="0" cy="0"/>
+        </a:xfrm>
+      </p:grpSpPr>
+      <p:sp>
+        <p:nvSpPr>
+          <p:cNvPr id="2" name="Slide Image Placeholder 1"/>
+          <p:cNvSpPr>
+            <a:spLocks noGrp="1"/>
+          </p:cNvSpPr>
+          <p:nvPr>
+            <p:ph type="sldImg" idx="2"/>
+          </p:nvPr>
+        </p:nvSpPr>
+        <p:spPr/>
+      </p:sp>
+      <p:sp>
+        <p:nvSpPr>
+          <p:cNvPr id="3" name="Notes Placeholder 2"/>
+          <p:cNvSpPr>
+            <a:spLocks noGrp="1"/>
+          </p:cNvSpPr>
+          <p:nvPr>
+            <p:ph type="body" idx="3" sz="quarter"/>
+          </p:nvPr>
+        </p:nvSpPr>
+        <p:spPr/>
+        <p:txBody>
+          <a:bodyPr/>
+          <a:lstStyle/>
+          <a:p>
+            <a:r>
+              <a:t>Backup, not presented</a:t>
+            </a:r>
+          </a:p>
+          <a:p>
+            <a:r>
+              <a:t>Answer questions on which concrete model stands behind each method name.</a:t>
+            </a:r>
+          </a:p>
+          <a:p>
+            <a:r>
+              <a:t>Sources (not spoken): README.md Models table; configs/benchmark.yaml roles; configs/models/*.yaml (svm calibration_cv 3; bilstm hidden_dim 256, layers 1; hybrid_knn intfloat/multilingual-e5-base, rrf_k 60; kev Kev-0.8B)</a:t>
             </a:r>
           </a:p>
         </p:txBody>
@@ -4034,7 +4115,7 @@
                 </a:solidFill>
                 <a:latin typeface="Arial"/>
               </a:rPr>
-              <a:t>Near-OOD rejection</a:t>
+              <a:t>Flag unfamiliar fields</a:t>
             </a:r>
           </a:p>
         </p:txBody>
@@ -5577,7 +5658,7 @@
                 </a:solidFill>
                 <a:latin typeface="Arial"/>
               </a:rPr>
-              <a:t>Same 473 labels for all · architecture → model</a:t>
+              <a:t>Every model predicts the same 473 labels</a:t>
             </a:r>
           </a:p>
         </p:txBody>
@@ -5623,14 +5704,58 @@
       </p:sp>
       <p:sp xmlns:a="http://schemas.openxmlformats.org/drawingml/2006/main">
         <p:nvSpPr>
-          <p:cNvPr id="5" name="TextBox 4"/>
+          <p:cNvPr id="5" name="Rectangle 4"/>
+          <p:cNvSpPr/>
+          <p:nvPr/>
+        </p:nvSpPr>
+        <p:spPr>
+          <a:xfrm>
+            <a:off x="609904" y="1874519"/>
+            <a:ext cx="5257800" cy="3291840"/>
+          </a:xfrm>
+          <a:prstGeom prst="rect">
+            <a:avLst/>
+          </a:prstGeom>
+          <a:solidFill>
+            <a:srgbClr val="EEF3F8"/>
+          </a:solidFill>
+          <a:ln>
+            <a:noFill/>
+          </a:ln>
+          <a:effectLst/>
+        </p:spPr>
+        <p:style>
+          <a:lnRef idx="1">
+            <a:schemeClr val="accent1"/>
+          </a:lnRef>
+          <a:fillRef idx="3">
+            <a:schemeClr val="accent1"/>
+          </a:fillRef>
+          <a:effectRef idx="2">
+            <a:schemeClr val="accent1"/>
+          </a:effectRef>
+          <a:fontRef idx="minor">
+            <a:schemeClr val="lt1"/>
+          </a:fontRef>
+        </p:style>
+        <p:txBody>
+          <a:bodyPr rtlCol="0" anchor="ctr"/>
+          <a:lstStyle/>
+          <a:p>
+            <a:pPr algn="ctr"/>
+          </a:p>
+        </p:txBody>
+      </p:sp>
+      <p:sp xmlns:a="http://schemas.openxmlformats.org/drawingml/2006/main">
+        <p:nvSpPr>
+          <p:cNvPr id="6" name="TextBox 5"/>
           <p:cNvSpPr txBox="1"/>
           <p:nvPr/>
         </p:nvSpPr>
         <p:spPr>
           <a:xfrm>
-            <a:off x="609904" y="1828800"/>
-            <a:ext cx="4846320" cy="384048"/>
+            <a:off x="884224" y="2103120"/>
+            <a:ext cx="4709160" cy="457200"/>
           </a:xfrm>
           <a:prstGeom prst="rect">
             <a:avLst/>
@@ -5649,7 +5774,7 @@
               </a:spcAft>
             </a:pPr>
             <a:r>
-              <a:rPr sz="2200" b="1" i="0">
+              <a:rPr sz="2600" b="1" i="0">
                 <a:solidFill>
                   <a:srgbClr val="12283D"/>
                 </a:solidFill>
@@ -5662,14 +5787,14 @@
       </p:sp>
       <p:sp xmlns:a="http://schemas.openxmlformats.org/drawingml/2006/main">
         <p:nvSpPr>
-          <p:cNvPr id="6" name="TextBox 5"/>
+          <p:cNvPr id="7" name="TextBox 6"/>
           <p:cNvSpPr txBox="1"/>
           <p:nvPr/>
         </p:nvSpPr>
         <p:spPr>
           <a:xfrm>
-            <a:off x="609904" y="2331720"/>
-            <a:ext cx="4846320" cy="685800"/>
+            <a:off x="884224" y="2743200"/>
+            <a:ext cx="4709160" cy="457200"/>
           </a:xfrm>
           <a:prstGeom prst="rect">
             <a:avLst/>
@@ -5688,7 +5813,7 @@
               </a:spcAft>
             </a:pPr>
             <a:r>
-              <a:rPr sz="1800" b="1" i="0">
+              <a:rPr sz="2400" b="1" i="0">
                 <a:solidFill>
                   <a:srgbClr val="2878B5"/>
                 </a:solidFill>
@@ -5697,34 +5822,18 @@
               <a:t>Naive Bayes</a:t>
             </a:r>
           </a:p>
-          <a:p>
-            <a:pPr algn="l">
-              <a:spcAft>
-                <a:spcPts val="0"/>
-              </a:spcAft>
-            </a:pPr>
-            <a:r>
-              <a:rPr sz="1800" b="0" i="0">
-                <a:solidFill>
-                  <a:srgbClr val="12283D"/>
-                </a:solidFill>
-                <a:latin typeface="Arial"/>
-              </a:rPr>
-              <a:t>→ MultinomialNB on TF-IDF</a:t>
-            </a:r>
-          </a:p>
         </p:txBody>
       </p:sp>
       <p:sp xmlns:a="http://schemas.openxmlformats.org/drawingml/2006/main">
         <p:nvSpPr>
-          <p:cNvPr id="7" name="TextBox 6"/>
+          <p:cNvPr id="8" name="TextBox 7"/>
           <p:cNvSpPr txBox="1"/>
           <p:nvPr/>
         </p:nvSpPr>
         <p:spPr>
           <a:xfrm>
-            <a:off x="609904" y="3081527"/>
-            <a:ext cx="4846320" cy="685800"/>
+            <a:off x="884224" y="3291840"/>
+            <a:ext cx="4709160" cy="457200"/>
           </a:xfrm>
           <a:prstGeom prst="rect">
             <a:avLst/>
@@ -5743,7 +5852,7 @@
               </a:spcAft>
             </a:pPr>
             <a:r>
-              <a:rPr sz="1800" b="1" i="0">
+              <a:rPr sz="2400" b="1" i="0">
                 <a:solidFill>
                   <a:srgbClr val="2878B5"/>
                 </a:solidFill>
@@ -5752,34 +5861,18 @@
               <a:t>Linear SVM</a:t>
             </a:r>
           </a:p>
-          <a:p>
-            <a:pPr algn="l">
-              <a:spcAft>
-                <a:spcPts val="0"/>
-              </a:spcAft>
-            </a:pPr>
-            <a:r>
-              <a:rPr sz="1800" b="0" i="0">
-                <a:solidFill>
-                  <a:srgbClr val="12283D"/>
-                </a:solidFill>
-                <a:latin typeface="Arial"/>
-              </a:rPr>
-              <a:t>→ LinearSVC + Platt, TF-IDF</a:t>
-            </a:r>
-          </a:p>
         </p:txBody>
       </p:sp>
       <p:sp xmlns:a="http://schemas.openxmlformats.org/drawingml/2006/main">
         <p:nvSpPr>
-          <p:cNvPr id="8" name="TextBox 7"/>
+          <p:cNvPr id="9" name="TextBox 8"/>
           <p:cNvSpPr txBox="1"/>
           <p:nvPr/>
         </p:nvSpPr>
         <p:spPr>
           <a:xfrm>
-            <a:off x="609904" y="3831335"/>
-            <a:ext cx="4846320" cy="685800"/>
+            <a:off x="884224" y="3840480"/>
+            <a:ext cx="4709160" cy="457200"/>
           </a:xfrm>
           <a:prstGeom prst="rect">
             <a:avLst/>
@@ -5798,7 +5891,7 @@
               </a:spcAft>
             </a:pPr>
             <a:r>
-              <a:rPr sz="1800" b="1" i="0">
+              <a:rPr sz="2400" b="1" i="0">
                 <a:solidFill>
                   <a:srgbClr val="2878B5"/>
                 </a:solidFill>
@@ -5807,34 +5900,18 @@
               <a:t>BiLSTM</a:t>
             </a:r>
           </a:p>
-          <a:p>
-            <a:pPr algn="l">
-              <a:spcAft>
-                <a:spcPts val="0"/>
-              </a:spcAft>
-            </a:pPr>
-            <a:r>
-              <a:rPr sz="1800" b="0" i="0">
-                <a:solidFill>
-                  <a:srgbClr val="12283D"/>
-                </a:solidFill>
-                <a:latin typeface="Arial"/>
-              </a:rPr>
-              <a:t>→ 1 layer × 256, from scratch</a:t>
-            </a:r>
-          </a:p>
         </p:txBody>
       </p:sp>
       <p:sp xmlns:a="http://schemas.openxmlformats.org/drawingml/2006/main">
         <p:nvSpPr>
-          <p:cNvPr id="9" name="TextBox 8"/>
+          <p:cNvPr id="10" name="TextBox 9"/>
           <p:cNvSpPr txBox="1"/>
           <p:nvPr/>
         </p:nvSpPr>
         <p:spPr>
           <a:xfrm>
-            <a:off x="609904" y="4581144"/>
-            <a:ext cx="4846320" cy="685800"/>
+            <a:off x="884224" y="4389120"/>
+            <a:ext cx="4709160" cy="457200"/>
           </a:xfrm>
           <a:prstGeom prst="rect">
             <a:avLst/>
@@ -5853,43 +5930,71 @@
               </a:spcAft>
             </a:pPr>
             <a:r>
-              <a:rPr sz="1800" b="1" i="0">
+              <a:rPr sz="2400" b="1" i="0">
                 <a:solidFill>
                   <a:srgbClr val="2878B5"/>
                 </a:solidFill>
                 <a:latin typeface="Arial"/>
               </a:rPr>
-              <a:t>Transformer</a:t>
-            </a:r>
-          </a:p>
-          <a:p>
-            <a:pPr algn="l">
-              <a:spcAft>
-                <a:spcPts val="0"/>
-              </a:spcAft>
-            </a:pPr>
-            <a:r>
-              <a:rPr sz="1800" b="0" i="0">
-                <a:solidFill>
-                  <a:srgbClr val="12283D"/>
-                </a:solidFill>
-                <a:latin typeface="Arial"/>
-              </a:rPr>
-              <a:t>→ xlm-roberta-base, fine-tuned</a:t>
+              <a:t>XLM-R</a:t>
             </a:r>
           </a:p>
         </p:txBody>
       </p:sp>
       <p:sp xmlns:a="http://schemas.openxmlformats.org/drawingml/2006/main">
         <p:nvSpPr>
-          <p:cNvPr id="10" name="TextBox 9"/>
+          <p:cNvPr id="11" name="Rectangle 10"/>
+          <p:cNvSpPr/>
+          <p:nvPr/>
+        </p:nvSpPr>
+        <p:spPr>
+          <a:xfrm>
+            <a:off x="6324904" y="1874519"/>
+            <a:ext cx="5257800" cy="3291840"/>
+          </a:xfrm>
+          <a:prstGeom prst="rect">
+            <a:avLst/>
+          </a:prstGeom>
+          <a:solidFill>
+            <a:srgbClr val="EEF3F8"/>
+          </a:solidFill>
+          <a:ln>
+            <a:noFill/>
+          </a:ln>
+          <a:effectLst/>
+        </p:spPr>
+        <p:style>
+          <a:lnRef idx="1">
+            <a:schemeClr val="accent1"/>
+          </a:lnRef>
+          <a:fillRef idx="3">
+            <a:schemeClr val="accent1"/>
+          </a:fillRef>
+          <a:effectRef idx="2">
+            <a:schemeClr val="accent1"/>
+          </a:effectRef>
+          <a:fontRef idx="minor">
+            <a:schemeClr val="lt1"/>
+          </a:fontRef>
+        </p:style>
+        <p:txBody>
+          <a:bodyPr rtlCol="0" anchor="ctr"/>
+          <a:lstStyle/>
+          <a:p>
+            <a:pPr algn="ctr"/>
+          </a:p>
+        </p:txBody>
+      </p:sp>
+      <p:sp xmlns:a="http://schemas.openxmlformats.org/drawingml/2006/main">
+        <p:nvSpPr>
+          <p:cNvPr id="12" name="TextBox 11"/>
           <p:cNvSpPr txBox="1"/>
           <p:nvPr/>
         </p:nvSpPr>
         <p:spPr>
           <a:xfrm>
-            <a:off x="5730544" y="1828800"/>
-            <a:ext cx="5852160" cy="384048"/>
+            <a:off x="6599224" y="2103120"/>
+            <a:ext cx="4709160" cy="457200"/>
           </a:xfrm>
           <a:prstGeom prst="rect">
             <a:avLst/>
@@ -5908,7 +6013,7 @@
               </a:spcAft>
             </a:pPr>
             <a:r>
-              <a:rPr sz="2200" b="1" i="0">
+              <a:rPr sz="2600" b="1" i="0">
                 <a:solidFill>
                   <a:srgbClr val="12283D"/>
                 </a:solidFill>
@@ -5921,14 +6026,14 @@
       </p:sp>
       <p:sp xmlns:a="http://schemas.openxmlformats.org/drawingml/2006/main">
         <p:nvSpPr>
-          <p:cNvPr id="11" name="TextBox 10"/>
+          <p:cNvPr id="13" name="TextBox 12"/>
           <p:cNvSpPr txBox="1"/>
           <p:nvPr/>
         </p:nvSpPr>
         <p:spPr>
           <a:xfrm>
-            <a:off x="5730544" y="2331720"/>
-            <a:ext cx="5852160" cy="685800"/>
+            <a:off x="6599224" y="2743200"/>
+            <a:ext cx="4709160" cy="457200"/>
           </a:xfrm>
           <a:prstGeom prst="rect">
             <a:avLst/>
@@ -5947,43 +6052,27 @@
               </a:spcAft>
             </a:pPr>
             <a:r>
-              <a:rPr sz="1800" b="1" i="0">
+              <a:rPr sz="2400" b="1" i="0">
                 <a:solidFill>
                   <a:srgbClr val="2878B5"/>
                 </a:solidFill>
                 <a:latin typeface="Arial"/>
               </a:rPr>
-              <a:t>Sparse + dense kNN</a:t>
-            </a:r>
-          </a:p>
-          <a:p>
-            <a:pPr algn="l">
-              <a:spcAft>
-                <a:spcPts val="0"/>
-              </a:spcAft>
-            </a:pPr>
-            <a:r>
-              <a:rPr sz="1800" b="0" i="0">
-                <a:solidFill>
-                  <a:srgbClr val="12283D"/>
-                </a:solidFill>
-                <a:latin typeface="Arial"/>
-              </a:rPr>
-              <a:t>→ TF-IDF + multilingual-e5-base</a:t>
+              <a:t>Hybrid kNN</a:t>
             </a:r>
           </a:p>
         </p:txBody>
       </p:sp>
       <p:sp xmlns:a="http://schemas.openxmlformats.org/drawingml/2006/main">
         <p:nvSpPr>
-          <p:cNvPr id="12" name="TextBox 11"/>
+          <p:cNvPr id="14" name="TextBox 13"/>
           <p:cNvSpPr txBox="1"/>
           <p:nvPr/>
         </p:nvSpPr>
         <p:spPr>
           <a:xfrm>
-            <a:off x="5730544" y="3081527"/>
-            <a:ext cx="5852160" cy="685800"/>
+            <a:off x="6599224" y="3291840"/>
+            <a:ext cx="4709160" cy="457200"/>
           </a:xfrm>
           <a:prstGeom prst="rect">
             <a:avLst/>
@@ -6002,43 +6091,27 @@
               </a:spcAft>
             </a:pPr>
             <a:r>
-              <a:rPr sz="1800" b="1" i="0">
+              <a:rPr sz="2400" b="1" i="0">
                 <a:solidFill>
                   <a:srgbClr val="2878B5"/>
                 </a:solidFill>
                 <a:latin typeface="Arial"/>
               </a:rPr>
-              <a:t>Voting ensembles</a:t>
-            </a:r>
-          </a:p>
-          <a:p>
-            <a:pPr algn="l">
-              <a:spcAft>
-                <a:spcPts val="0"/>
-              </a:spcAft>
-            </a:pPr>
-            <a:r>
-              <a:rPr sz="1800" b="0" i="0">
-                <a:solidFill>
-                  <a:srgbClr val="12283D"/>
-                </a:solidFill>
-                <a:latin typeface="Arial"/>
-              </a:rPr>
-              <a:t>→ SVM, kNN, BiLSTM, XLM-R (+ Kev, Jev on sample)</a:t>
+              <a:t>NALTRA votes</a:t>
             </a:r>
           </a:p>
         </p:txBody>
       </p:sp>
       <p:sp xmlns:a="http://schemas.openxmlformats.org/drawingml/2006/main">
         <p:nvSpPr>
-          <p:cNvPr id="13" name="TextBox 12"/>
+          <p:cNvPr id="15" name="TextBox 14"/>
           <p:cNvSpPr txBox="1"/>
           <p:nvPr/>
         </p:nvSpPr>
         <p:spPr>
           <a:xfrm>
-            <a:off x="5730544" y="3831335"/>
-            <a:ext cx="5852160" cy="685800"/>
+            <a:off x="6599224" y="3840480"/>
+            <a:ext cx="4709160" cy="457200"/>
           </a:xfrm>
           <a:prstGeom prst="rect">
             <a:avLst/>
@@ -6057,43 +6130,36 @@
               </a:spcAft>
             </a:pPr>
             <a:r>
-              <a:rPr sz="1800" b="1" i="0">
+              <a:rPr sz="2400" b="1" i="0">
+                <a:solidFill>
+                  <a:srgbClr val="516170"/>
+                </a:solidFill>
+                <a:latin typeface="Arial"/>
+              </a:rPr>
+              <a:t>zero-shot </a:t>
+            </a:r>
+            <a:r>
+              <a:rPr sz="2400" b="1" i="0">
                 <a:solidFill>
                   <a:srgbClr val="2878B5"/>
                 </a:solidFill>
                 <a:latin typeface="Arial"/>
               </a:rPr>
-              <a:t>Zero-shot yes/no</a:t>
-            </a:r>
-          </a:p>
-          <a:p>
-            <a:pPr algn="l">
-              <a:spcAft>
-                <a:spcPts val="0"/>
-              </a:spcAft>
-            </a:pPr>
-            <a:r>
-              <a:rPr sz="1800" b="0" i="0">
-                <a:solidFill>
-                  <a:srgbClr val="12283D"/>
-                </a:solidFill>
-                <a:latin typeface="Arial"/>
-              </a:rPr>
-              <a:t>→ Kev-0.8B (local), Jev (hosted)</a:t>
+              <a:t>Kev, Jev, Laya</a:t>
             </a:r>
           </a:p>
         </p:txBody>
       </p:sp>
       <p:sp xmlns:a="http://schemas.openxmlformats.org/drawingml/2006/main">
         <p:nvSpPr>
-          <p:cNvPr id="14" name="TextBox 13"/>
+          <p:cNvPr id="16" name="TextBox 15"/>
           <p:cNvSpPr txBox="1"/>
           <p:nvPr/>
         </p:nvSpPr>
         <p:spPr>
           <a:xfrm>
-            <a:off x="5730544" y="4581144"/>
-            <a:ext cx="5852160" cy="685800"/>
+            <a:off x="609904" y="5486400"/>
+            <a:ext cx="10972800" cy="457200"/>
           </a:xfrm>
           <a:prstGeom prst="rect">
             <a:avLst/>
@@ -6112,68 +6178,22 @@
               </a:spcAft>
             </a:pPr>
             <a:r>
-              <a:rPr sz="1800" b="1" i="0">
-                <a:solidFill>
-                  <a:srgbClr val="2878B5"/>
-                </a:solidFill>
-                <a:latin typeface="Arial"/>
-              </a:rPr>
-              <a:t>Zero-shot choice</a:t>
-            </a:r>
-          </a:p>
-          <a:p>
-            <a:pPr algn="l">
-              <a:spcAft>
-                <a:spcPts val="0"/>
-              </a:spcAft>
-            </a:pPr>
-            <a:r>
-              <a:rPr sz="1800" b="0" i="0">
+              <a:rPr sz="2000" b="1" i="0">
                 <a:solidFill>
                   <a:srgbClr val="12283D"/>
                 </a:solidFill>
                 <a:latin typeface="Arial"/>
               </a:rPr>
-              <a:t>→ convaiinnovations/laya</a:t>
+              <a:t>Metric: micro-F1</a:t>
             </a:r>
-          </a:p>
-        </p:txBody>
-      </p:sp>
-      <p:sp xmlns:a="http://schemas.openxmlformats.org/drawingml/2006/main">
-        <p:nvSpPr>
-          <p:cNvPr id="15" name="TextBox 14"/>
-          <p:cNvSpPr txBox="1"/>
-          <p:nvPr/>
-        </p:nvSpPr>
-        <p:spPr>
-          <a:xfrm>
-            <a:off x="609904" y="5532120"/>
-            <a:ext cx="10972800" cy="411480"/>
-          </a:xfrm>
-          <a:prstGeom prst="rect">
-            <a:avLst/>
-          </a:prstGeom>
-          <a:noFill/>
-        </p:spPr>
-        <p:txBody>
-          <a:bodyPr wrap="square" anchor="t" lIns="0" rIns="0" tIns="0" bIns="0">
-            <a:noAutofit/>
-          </a:bodyPr>
-          <a:lstStyle/>
-          <a:p>
-            <a:pPr algn="l">
-              <a:spcAft>
-                <a:spcPts val="0"/>
-              </a:spcAft>
-            </a:pPr>
             <a:r>
-              <a:rPr sz="1800" b="0" i="0">
+              <a:rPr sz="2000" b="0" i="0">
                 <a:solidFill>
-                  <a:srgbClr val="516170"/>
+                  <a:srgbClr val="12283D"/>
                 </a:solidFill>
                 <a:latin typeface="Arial"/>
               </a:rPr>
-              <a:t>Metric: micro-F1, as predicting no label already scores 99.3% accuracy</a:t>
+              <a:t>, as predicting no label already scores 99.3% accuracy</a:t>
             </a:r>
           </a:p>
         </p:txBody>
@@ -12278,6 +12298,1539 @@
                 <a:latin typeface="Arial"/>
               </a:rPr>
               <a:t>OOD at 95% recall of humanities: SVM still flags 32% EN / 28% TR in-domain projects.</a:t>
+            </a:r>
+          </a:p>
+        </p:txBody>
+      </p:sp>
+    </p:spTree>
+  </p:cSld>
+  <p:clrMapOvr>
+    <a:masterClrMapping/>
+  </p:clrMapOvr>
+</p:sld>
+</file>
+
+<file path=ppt/slides/slide8.xml><?xml version="1.0" encoding="utf-8"?>
+<p:sld xmlns:a="http://schemas.openxmlformats.org/drawingml/2006/main" xmlns:p="http://schemas.openxmlformats.org/presentationml/2006/main" xmlns:r="http://schemas.openxmlformats.org/officeDocument/2006/relationships" show="0">
+  <p:cSld>
+    <p:bg>
+      <p:bgPr>
+        <a:solidFill>
+          <a:srgbClr val="FFFFFF"/>
+        </a:solidFill>
+        <a:effectLst/>
+      </p:bgPr>
+    </p:bg>
+    <p:spTree>
+      <p:nvGrpSpPr>
+        <p:cNvPr id="1" name=""/>
+        <p:cNvGrpSpPr/>
+        <p:nvPr/>
+      </p:nvGrpSpPr>
+      <p:grpSpPr/>
+      <p:sp>
+        <p:nvSpPr>
+          <p:cNvPr id="2" name="TextBox 1"/>
+          <p:cNvSpPr txBox="1"/>
+          <p:nvPr/>
+        </p:nvSpPr>
+        <p:spPr>
+          <a:xfrm>
+            <a:off x="609904" y="457200"/>
+            <a:ext cx="10972800" cy="667512"/>
+          </a:xfrm>
+          <a:prstGeom prst="rect">
+            <a:avLst/>
+          </a:prstGeom>
+          <a:noFill/>
+        </p:spPr>
+        <p:txBody>
+          <a:bodyPr wrap="square" anchor="t" lIns="0" rIns="0" tIns="0" bIns="0">
+            <a:noAutofit/>
+          </a:bodyPr>
+          <a:lstStyle/>
+          <a:p>
+            <a:pPr algn="l">
+              <a:spcAft>
+                <a:spcPts val="0"/>
+              </a:spcAft>
+            </a:pPr>
+            <a:r>
+              <a:rPr sz="3600" b="1" i="0">
+                <a:solidFill>
+                  <a:srgbClr val="12283D"/>
+                </a:solidFill>
+                <a:latin typeface="Arial"/>
+              </a:rPr>
+              <a:t>Backup: architectures and models</a:t>
+            </a:r>
+          </a:p>
+        </p:txBody>
+      </p:sp>
+      <p:sp>
+        <p:nvSpPr>
+          <p:cNvPr id="3" name="TextBox 2"/>
+          <p:cNvSpPr txBox="1"/>
+          <p:nvPr/>
+        </p:nvSpPr>
+        <p:spPr>
+          <a:xfrm>
+            <a:off x="609904" y="1179576"/>
+            <a:ext cx="10972800" cy="402336"/>
+          </a:xfrm>
+          <a:prstGeom prst="rect">
+            <a:avLst/>
+          </a:prstGeom>
+          <a:noFill/>
+        </p:spPr>
+        <p:txBody>
+          <a:bodyPr wrap="square" anchor="t" lIns="0" rIns="0" tIns="0" bIns="0">
+            <a:noAutofit/>
+          </a:bodyPr>
+          <a:lstStyle/>
+          <a:p>
+            <a:pPr algn="l">
+              <a:spcAft>
+                <a:spcPts val="0"/>
+              </a:spcAft>
+            </a:pPr>
+            <a:r>
+              <a:rPr sz="1900" b="0" i="0">
+                <a:solidFill>
+                  <a:srgbClr val="516170"/>
+                </a:solidFill>
+                <a:latin typeface="Arial"/>
+              </a:rPr>
+              <a:t>Architecture → concrete model behind each name on slide 3</a:t>
+            </a:r>
+          </a:p>
+        </p:txBody>
+      </p:sp>
+      <p:sp>
+        <p:nvSpPr>
+          <p:cNvPr id="4" name="TextBox 3"/>
+          <p:cNvSpPr txBox="1"/>
+          <p:nvPr/>
+        </p:nvSpPr>
+        <p:spPr>
+          <a:xfrm>
+            <a:off x="9966960" y="6400800"/>
+            <a:ext cx="1618488" cy="228600"/>
+          </a:xfrm>
+          <a:prstGeom prst="rect">
+            <a:avLst/>
+          </a:prstGeom>
+          <a:noFill/>
+        </p:spPr>
+        <p:txBody>
+          <a:bodyPr wrap="square" anchor="t" lIns="0" rIns="0" tIns="0" bIns="0">
+            <a:noAutofit/>
+          </a:bodyPr>
+          <a:lstStyle/>
+          <a:p>
+            <a:pPr algn="r">
+              <a:spcAft>
+                <a:spcPts val="0"/>
+              </a:spcAft>
+            </a:pPr>
+            <a:r>
+              <a:rPr sz="1400" b="0" i="0">
+                <a:solidFill>
+                  <a:srgbClr val="516170"/>
+                </a:solidFill>
+                <a:latin typeface="Arial"/>
+              </a:rPr>
+              <a:t>Backup B3</a:t>
+            </a:r>
+          </a:p>
+        </p:txBody>
+      </p:sp>
+      <p:graphicFrame>
+        <p:nvGraphicFramePr>
+          <p:cNvPr id="5" name="Table 4"/>
+          <p:cNvGraphicFramePr>
+            <a:graphicFrameLocks noGrp="1"/>
+          </p:cNvGraphicFramePr>
+          <p:nvPr/>
+        </p:nvGraphicFramePr>
+        <p:xfrm>
+          <a:off x="609904" y="1737360"/>
+          <a:ext cx="10972800" cy="3657600"/>
+        </p:xfrm>
+        <a:graphic>
+          <a:graphicData uri="http://schemas.openxmlformats.org/drawingml/2006/table">
+            <a:tbl>
+              <a:tblPr firstRow="1" bandRow="0"/>
+              <a:tblGrid>
+                <a:gridCol w="2103120"/>
+                <a:gridCol w="1280160"/>
+                <a:gridCol w="7589520"/>
+              </a:tblGrid>
+              <a:tr h="365760">
+                <a:tc>
+                  <a:txBody>
+                    <a:bodyPr/>
+                    <a:lstStyle/>
+                    <a:p>
+                      <a:pPr algn="l"/>
+                      <a:r>
+                        <a:rPr sz="1600" b="1" i="0">
+                          <a:solidFill>
+                            <a:srgbClr val="FFFFFF"/>
+                          </a:solidFill>
+                          <a:latin typeface="Arial"/>
+                        </a:rPr>
+                        <a:t>Model</a:t>
+                      </a:r>
+                    </a:p>
+                  </a:txBody>
+                  <a:tcPr marL="73152" marR="73152" marT="18288" marB="18288" anchor="ctr">
+                    <a:lnL w="9525">
+                      <a:solidFill>
+                        <a:srgbClr val="BED3E5"/>
+                      </a:solidFill>
+                    </a:lnL>
+                    <a:lnR w="9525">
+                      <a:solidFill>
+                        <a:srgbClr val="BED3E5"/>
+                      </a:solidFill>
+                    </a:lnR>
+                    <a:lnT w="9525">
+                      <a:solidFill>
+                        <a:srgbClr val="BED3E5"/>
+                      </a:solidFill>
+                    </a:lnT>
+                    <a:lnB w="9525">
+                      <a:solidFill>
+                        <a:srgbClr val="BED3E5"/>
+                      </a:solidFill>
+                    </a:lnB>
+                    <a:solidFill>
+                      <a:srgbClr val="12283D"/>
+                    </a:solidFill>
+                  </a:tcPr>
+                </a:tc>
+                <a:tc>
+                  <a:txBody>
+                    <a:bodyPr/>
+                    <a:lstStyle/>
+                    <a:p>
+                      <a:pPr algn="ctr"/>
+                      <a:r>
+                        <a:rPr sz="1600" b="1" i="0">
+                          <a:solidFill>
+                            <a:srgbClr val="FFFFFF"/>
+                          </a:solidFill>
+                          <a:latin typeface="Arial"/>
+                        </a:rPr>
+                        <a:t>Role</a:t>
+                      </a:r>
+                    </a:p>
+                  </a:txBody>
+                  <a:tcPr marL="73152" marR="73152" marT="18288" marB="18288" anchor="ctr">
+                    <a:lnL w="9525">
+                      <a:solidFill>
+                        <a:srgbClr val="BED3E5"/>
+                      </a:solidFill>
+                    </a:lnL>
+                    <a:lnR w="9525">
+                      <a:solidFill>
+                        <a:srgbClr val="BED3E5"/>
+                      </a:solidFill>
+                    </a:lnR>
+                    <a:lnT w="9525">
+                      <a:solidFill>
+                        <a:srgbClr val="BED3E5"/>
+                      </a:solidFill>
+                    </a:lnT>
+                    <a:lnB w="9525">
+                      <a:solidFill>
+                        <a:srgbClr val="BED3E5"/>
+                      </a:solidFill>
+                    </a:lnB>
+                    <a:solidFill>
+                      <a:srgbClr val="12283D"/>
+                    </a:solidFill>
+                  </a:tcPr>
+                </a:tc>
+                <a:tc>
+                  <a:txBody>
+                    <a:bodyPr/>
+                    <a:lstStyle/>
+                    <a:p>
+                      <a:pPr algn="ctr"/>
+                      <a:r>
+                        <a:rPr sz="1600" b="1" i="0">
+                          <a:solidFill>
+                            <a:srgbClr val="FFFFFF"/>
+                          </a:solidFill>
+                          <a:latin typeface="Arial"/>
+                        </a:rPr>
+                        <a:t>Architecture → model</a:t>
+                      </a:r>
+                    </a:p>
+                  </a:txBody>
+                  <a:tcPr marL="73152" marR="73152" marT="18288" marB="18288" anchor="ctr">
+                    <a:lnL w="9525">
+                      <a:solidFill>
+                        <a:srgbClr val="BED3E5"/>
+                      </a:solidFill>
+                    </a:lnL>
+                    <a:lnR w="9525">
+                      <a:solidFill>
+                        <a:srgbClr val="BED3E5"/>
+                      </a:solidFill>
+                    </a:lnR>
+                    <a:lnT w="9525">
+                      <a:solidFill>
+                        <a:srgbClr val="BED3E5"/>
+                      </a:solidFill>
+                    </a:lnT>
+                    <a:lnB w="9525">
+                      <a:solidFill>
+                        <a:srgbClr val="BED3E5"/>
+                      </a:solidFill>
+                    </a:lnB>
+                    <a:solidFill>
+                      <a:srgbClr val="12283D"/>
+                    </a:solidFill>
+                  </a:tcPr>
+                </a:tc>
+              </a:tr>
+              <a:tr h="365760">
+                <a:tc>
+                  <a:txBody>
+                    <a:bodyPr/>
+                    <a:lstStyle/>
+                    <a:p>
+                      <a:pPr algn="l"/>
+                      <a:r>
+                        <a:rPr sz="1600" b="0" i="0">
+                          <a:solidFill>
+                            <a:srgbClr val="12283D"/>
+                          </a:solidFill>
+                          <a:latin typeface="Arial"/>
+                        </a:rPr>
+                        <a:t>Naive Bayes</a:t>
+                      </a:r>
+                    </a:p>
+                  </a:txBody>
+                  <a:tcPr marL="73152" marR="73152" marT="18288" marB="18288" anchor="ctr">
+                    <a:lnL w="9525">
+                      <a:solidFill>
+                        <a:srgbClr val="BED3E5"/>
+                      </a:solidFill>
+                    </a:lnL>
+                    <a:lnR w="9525">
+                      <a:solidFill>
+                        <a:srgbClr val="BED3E5"/>
+                      </a:solidFill>
+                    </a:lnR>
+                    <a:lnT w="9525">
+                      <a:solidFill>
+                        <a:srgbClr val="BED3E5"/>
+                      </a:solidFill>
+                    </a:lnT>
+                    <a:lnB w="9525">
+                      <a:solidFill>
+                        <a:srgbClr val="BED3E5"/>
+                      </a:solidFill>
+                    </a:lnB>
+                    <a:solidFill>
+                      <a:srgbClr val="FFFFFF"/>
+                    </a:solidFill>
+                  </a:tcPr>
+                </a:tc>
+                <a:tc>
+                  <a:txBody>
+                    <a:bodyPr/>
+                    <a:lstStyle/>
+                    <a:p>
+                      <a:pPr algn="ctr"/>
+                      <a:r>
+                        <a:rPr sz="1600" b="0" i="0">
+                          <a:solidFill>
+                            <a:srgbClr val="12283D"/>
+                          </a:solidFill>
+                          <a:latin typeface="Arial"/>
+                        </a:rPr>
+                        <a:t>baseline</a:t>
+                      </a:r>
+                    </a:p>
+                  </a:txBody>
+                  <a:tcPr marL="73152" marR="73152" marT="18288" marB="18288" anchor="ctr">
+                    <a:lnL w="9525">
+                      <a:solidFill>
+                        <a:srgbClr val="BED3E5"/>
+                      </a:solidFill>
+                    </a:lnL>
+                    <a:lnR w="9525">
+                      <a:solidFill>
+                        <a:srgbClr val="BED3E5"/>
+                      </a:solidFill>
+                    </a:lnR>
+                    <a:lnT w="9525">
+                      <a:solidFill>
+                        <a:srgbClr val="BED3E5"/>
+                      </a:solidFill>
+                    </a:lnT>
+                    <a:lnB w="9525">
+                      <a:solidFill>
+                        <a:srgbClr val="BED3E5"/>
+                      </a:solidFill>
+                    </a:lnB>
+                    <a:solidFill>
+                      <a:srgbClr val="FFFFFF"/>
+                    </a:solidFill>
+                  </a:tcPr>
+                </a:tc>
+                <a:tc>
+                  <a:txBody>
+                    <a:bodyPr/>
+                    <a:lstStyle/>
+                    <a:p>
+                      <a:pPr algn="ctr"/>
+                      <a:r>
+                        <a:rPr sz="1600" b="0" i="0">
+                          <a:solidFill>
+                            <a:srgbClr val="12283D"/>
+                          </a:solidFill>
+                          <a:latin typeface="Arial"/>
+                        </a:rPr>
+                        <a:t>MultinomialNB on TF-IDF</a:t>
+                      </a:r>
+                    </a:p>
+                  </a:txBody>
+                  <a:tcPr marL="73152" marR="73152" marT="18288" marB="18288" anchor="ctr">
+                    <a:lnL w="9525">
+                      <a:solidFill>
+                        <a:srgbClr val="BED3E5"/>
+                      </a:solidFill>
+                    </a:lnL>
+                    <a:lnR w="9525">
+                      <a:solidFill>
+                        <a:srgbClr val="BED3E5"/>
+                      </a:solidFill>
+                    </a:lnR>
+                    <a:lnT w="9525">
+                      <a:solidFill>
+                        <a:srgbClr val="BED3E5"/>
+                      </a:solidFill>
+                    </a:lnT>
+                    <a:lnB w="9525">
+                      <a:solidFill>
+                        <a:srgbClr val="BED3E5"/>
+                      </a:solidFill>
+                    </a:lnB>
+                    <a:solidFill>
+                      <a:srgbClr val="FFFFFF"/>
+                    </a:solidFill>
+                  </a:tcPr>
+                </a:tc>
+              </a:tr>
+              <a:tr h="365760">
+                <a:tc>
+                  <a:txBody>
+                    <a:bodyPr/>
+                    <a:lstStyle/>
+                    <a:p>
+                      <a:pPr algn="l"/>
+                      <a:r>
+                        <a:rPr sz="1600" b="0" i="0">
+                          <a:solidFill>
+                            <a:srgbClr val="12283D"/>
+                          </a:solidFill>
+                          <a:latin typeface="Arial"/>
+                        </a:rPr>
+                        <a:t>Linear SVM</a:t>
+                      </a:r>
+                    </a:p>
+                  </a:txBody>
+                  <a:tcPr marL="73152" marR="73152" marT="18288" marB="18288" anchor="ctr">
+                    <a:lnL w="9525">
+                      <a:solidFill>
+                        <a:srgbClr val="BED3E5"/>
+                      </a:solidFill>
+                    </a:lnL>
+                    <a:lnR w="9525">
+                      <a:solidFill>
+                        <a:srgbClr val="BED3E5"/>
+                      </a:solidFill>
+                    </a:lnR>
+                    <a:lnT w="9525">
+                      <a:solidFill>
+                        <a:srgbClr val="BED3E5"/>
+                      </a:solidFill>
+                    </a:lnT>
+                    <a:lnB w="9525">
+                      <a:solidFill>
+                        <a:srgbClr val="BED3E5"/>
+                      </a:solidFill>
+                    </a:lnB>
+                    <a:solidFill>
+                      <a:srgbClr val="FFFFFF"/>
+                    </a:solidFill>
+                  </a:tcPr>
+                </a:tc>
+                <a:tc>
+                  <a:txBody>
+                    <a:bodyPr/>
+                    <a:lstStyle/>
+                    <a:p>
+                      <a:pPr algn="ctr"/>
+                      <a:r>
+                        <a:rPr sz="1600" b="0" i="0">
+                          <a:solidFill>
+                            <a:srgbClr val="12283D"/>
+                          </a:solidFill>
+                          <a:latin typeface="Arial"/>
+                        </a:rPr>
+                        <a:t>baseline</a:t>
+                      </a:r>
+                    </a:p>
+                  </a:txBody>
+                  <a:tcPr marL="73152" marR="73152" marT="18288" marB="18288" anchor="ctr">
+                    <a:lnL w="9525">
+                      <a:solidFill>
+                        <a:srgbClr val="BED3E5"/>
+                      </a:solidFill>
+                    </a:lnL>
+                    <a:lnR w="9525">
+                      <a:solidFill>
+                        <a:srgbClr val="BED3E5"/>
+                      </a:solidFill>
+                    </a:lnR>
+                    <a:lnT w="9525">
+                      <a:solidFill>
+                        <a:srgbClr val="BED3E5"/>
+                      </a:solidFill>
+                    </a:lnT>
+                    <a:lnB w="9525">
+                      <a:solidFill>
+                        <a:srgbClr val="BED3E5"/>
+                      </a:solidFill>
+                    </a:lnB>
+                    <a:solidFill>
+                      <a:srgbClr val="FFFFFF"/>
+                    </a:solidFill>
+                  </a:tcPr>
+                </a:tc>
+                <a:tc>
+                  <a:txBody>
+                    <a:bodyPr/>
+                    <a:lstStyle/>
+                    <a:p>
+                      <a:pPr algn="ctr"/>
+                      <a:r>
+                        <a:rPr sz="1600" b="0" i="0">
+                          <a:solidFill>
+                            <a:srgbClr val="12283D"/>
+                          </a:solidFill>
+                          <a:latin typeface="Arial"/>
+                        </a:rPr>
+                        <a:t>LinearSVC + Platt calibration, TF-IDF</a:t>
+                      </a:r>
+                    </a:p>
+                  </a:txBody>
+                  <a:tcPr marL="73152" marR="73152" marT="18288" marB="18288" anchor="ctr">
+                    <a:lnL w="9525">
+                      <a:solidFill>
+                        <a:srgbClr val="BED3E5"/>
+                      </a:solidFill>
+                    </a:lnL>
+                    <a:lnR w="9525">
+                      <a:solidFill>
+                        <a:srgbClr val="BED3E5"/>
+                      </a:solidFill>
+                    </a:lnR>
+                    <a:lnT w="9525">
+                      <a:solidFill>
+                        <a:srgbClr val="BED3E5"/>
+                      </a:solidFill>
+                    </a:lnT>
+                    <a:lnB w="9525">
+                      <a:solidFill>
+                        <a:srgbClr val="BED3E5"/>
+                      </a:solidFill>
+                    </a:lnB>
+                    <a:solidFill>
+                      <a:srgbClr val="FFFFFF"/>
+                    </a:solidFill>
+                  </a:tcPr>
+                </a:tc>
+              </a:tr>
+              <a:tr h="365760">
+                <a:tc>
+                  <a:txBody>
+                    <a:bodyPr/>
+                    <a:lstStyle/>
+                    <a:p>
+                      <a:pPr algn="l"/>
+                      <a:r>
+                        <a:rPr sz="1600" b="0" i="0">
+                          <a:solidFill>
+                            <a:srgbClr val="12283D"/>
+                          </a:solidFill>
+                          <a:latin typeface="Arial"/>
+                        </a:rPr>
+                        <a:t>BiLSTM</a:t>
+                      </a:r>
+                    </a:p>
+                  </a:txBody>
+                  <a:tcPr marL="73152" marR="73152" marT="18288" marB="18288" anchor="ctr">
+                    <a:lnL w="9525">
+                      <a:solidFill>
+                        <a:srgbClr val="BED3E5"/>
+                      </a:solidFill>
+                    </a:lnL>
+                    <a:lnR w="9525">
+                      <a:solidFill>
+                        <a:srgbClr val="BED3E5"/>
+                      </a:solidFill>
+                    </a:lnR>
+                    <a:lnT w="9525">
+                      <a:solidFill>
+                        <a:srgbClr val="BED3E5"/>
+                      </a:solidFill>
+                    </a:lnT>
+                    <a:lnB w="9525">
+                      <a:solidFill>
+                        <a:srgbClr val="BED3E5"/>
+                      </a:solidFill>
+                    </a:lnB>
+                    <a:solidFill>
+                      <a:srgbClr val="FFFFFF"/>
+                    </a:solidFill>
+                  </a:tcPr>
+                </a:tc>
+                <a:tc>
+                  <a:txBody>
+                    <a:bodyPr/>
+                    <a:lstStyle/>
+                    <a:p>
+                      <a:pPr algn="ctr"/>
+                      <a:r>
+                        <a:rPr sz="1600" b="0" i="0">
+                          <a:solidFill>
+                            <a:srgbClr val="12283D"/>
+                          </a:solidFill>
+                          <a:latin typeface="Arial"/>
+                        </a:rPr>
+                        <a:t>baseline</a:t>
+                      </a:r>
+                    </a:p>
+                  </a:txBody>
+                  <a:tcPr marL="73152" marR="73152" marT="18288" marB="18288" anchor="ctr">
+                    <a:lnL w="9525">
+                      <a:solidFill>
+                        <a:srgbClr val="BED3E5"/>
+                      </a:solidFill>
+                    </a:lnL>
+                    <a:lnR w="9525">
+                      <a:solidFill>
+                        <a:srgbClr val="BED3E5"/>
+                      </a:solidFill>
+                    </a:lnR>
+                    <a:lnT w="9525">
+                      <a:solidFill>
+                        <a:srgbClr val="BED3E5"/>
+                      </a:solidFill>
+                    </a:lnT>
+                    <a:lnB w="9525">
+                      <a:solidFill>
+                        <a:srgbClr val="BED3E5"/>
+                      </a:solidFill>
+                    </a:lnB>
+                    <a:solidFill>
+                      <a:srgbClr val="FFFFFF"/>
+                    </a:solidFill>
+                  </a:tcPr>
+                </a:tc>
+                <a:tc>
+                  <a:txBody>
+                    <a:bodyPr/>
+                    <a:lstStyle/>
+                    <a:p>
+                      <a:pPr algn="ctr"/>
+                      <a:r>
+                        <a:rPr sz="1600" b="0" i="0">
+                          <a:solidFill>
+                            <a:srgbClr val="12283D"/>
+                          </a:solidFill>
+                          <a:latin typeface="Arial"/>
+                        </a:rPr>
+                        <a:t>1 layer × 256, trained from scratch</a:t>
+                      </a:r>
+                    </a:p>
+                  </a:txBody>
+                  <a:tcPr marL="73152" marR="73152" marT="18288" marB="18288" anchor="ctr">
+                    <a:lnL w="9525">
+                      <a:solidFill>
+                        <a:srgbClr val="BED3E5"/>
+                      </a:solidFill>
+                    </a:lnL>
+                    <a:lnR w="9525">
+                      <a:solidFill>
+                        <a:srgbClr val="BED3E5"/>
+                      </a:solidFill>
+                    </a:lnR>
+                    <a:lnT w="9525">
+                      <a:solidFill>
+                        <a:srgbClr val="BED3E5"/>
+                      </a:solidFill>
+                    </a:lnT>
+                    <a:lnB w="9525">
+                      <a:solidFill>
+                        <a:srgbClr val="BED3E5"/>
+                      </a:solidFill>
+                    </a:lnB>
+                    <a:solidFill>
+                      <a:srgbClr val="FFFFFF"/>
+                    </a:solidFill>
+                  </a:tcPr>
+                </a:tc>
+              </a:tr>
+              <a:tr h="365760">
+                <a:tc>
+                  <a:txBody>
+                    <a:bodyPr/>
+                    <a:lstStyle/>
+                    <a:p>
+                      <a:pPr algn="l"/>
+                      <a:r>
+                        <a:rPr sz="1600" b="0" i="0">
+                          <a:solidFill>
+                            <a:srgbClr val="12283D"/>
+                          </a:solidFill>
+                          <a:latin typeface="Arial"/>
+                        </a:rPr>
+                        <a:t>XLM-R</a:t>
+                      </a:r>
+                    </a:p>
+                  </a:txBody>
+                  <a:tcPr marL="73152" marR="73152" marT="18288" marB="18288" anchor="ctr">
+                    <a:lnL w="9525">
+                      <a:solidFill>
+                        <a:srgbClr val="BED3E5"/>
+                      </a:solidFill>
+                    </a:lnL>
+                    <a:lnR w="9525">
+                      <a:solidFill>
+                        <a:srgbClr val="BED3E5"/>
+                      </a:solidFill>
+                    </a:lnR>
+                    <a:lnT w="9525">
+                      <a:solidFill>
+                        <a:srgbClr val="BED3E5"/>
+                      </a:solidFill>
+                    </a:lnT>
+                    <a:lnB w="9525">
+                      <a:solidFill>
+                        <a:srgbClr val="BED3E5"/>
+                      </a:solidFill>
+                    </a:lnB>
+                    <a:solidFill>
+                      <a:srgbClr val="FFFFFF"/>
+                    </a:solidFill>
+                  </a:tcPr>
+                </a:tc>
+                <a:tc>
+                  <a:txBody>
+                    <a:bodyPr/>
+                    <a:lstStyle/>
+                    <a:p>
+                      <a:pPr algn="ctr"/>
+                      <a:r>
+                        <a:rPr sz="1600" b="0" i="0">
+                          <a:solidFill>
+                            <a:srgbClr val="12283D"/>
+                          </a:solidFill>
+                          <a:latin typeface="Arial"/>
+                        </a:rPr>
+                        <a:t>baseline</a:t>
+                      </a:r>
+                    </a:p>
+                  </a:txBody>
+                  <a:tcPr marL="73152" marR="73152" marT="18288" marB="18288" anchor="ctr">
+                    <a:lnL w="9525">
+                      <a:solidFill>
+                        <a:srgbClr val="BED3E5"/>
+                      </a:solidFill>
+                    </a:lnL>
+                    <a:lnR w="9525">
+                      <a:solidFill>
+                        <a:srgbClr val="BED3E5"/>
+                      </a:solidFill>
+                    </a:lnR>
+                    <a:lnT w="9525">
+                      <a:solidFill>
+                        <a:srgbClr val="BED3E5"/>
+                      </a:solidFill>
+                    </a:lnT>
+                    <a:lnB w="9525">
+                      <a:solidFill>
+                        <a:srgbClr val="BED3E5"/>
+                      </a:solidFill>
+                    </a:lnB>
+                    <a:solidFill>
+                      <a:srgbClr val="FFFFFF"/>
+                    </a:solidFill>
+                  </a:tcPr>
+                </a:tc>
+                <a:tc>
+                  <a:txBody>
+                    <a:bodyPr/>
+                    <a:lstStyle/>
+                    <a:p>
+                      <a:pPr algn="ctr"/>
+                      <a:r>
+                        <a:rPr sz="1600" b="0" i="0">
+                          <a:solidFill>
+                            <a:srgbClr val="12283D"/>
+                          </a:solidFill>
+                          <a:latin typeface="Arial"/>
+                        </a:rPr>
+                        <a:t>xlm-roberta-base, fine-tuned</a:t>
+                      </a:r>
+                    </a:p>
+                  </a:txBody>
+                  <a:tcPr marL="73152" marR="73152" marT="18288" marB="18288" anchor="ctr">
+                    <a:lnL w="9525">
+                      <a:solidFill>
+                        <a:srgbClr val="BED3E5"/>
+                      </a:solidFill>
+                    </a:lnL>
+                    <a:lnR w="9525">
+                      <a:solidFill>
+                        <a:srgbClr val="BED3E5"/>
+                      </a:solidFill>
+                    </a:lnR>
+                    <a:lnT w="9525">
+                      <a:solidFill>
+                        <a:srgbClr val="BED3E5"/>
+                      </a:solidFill>
+                    </a:lnT>
+                    <a:lnB w="9525">
+                      <a:solidFill>
+                        <a:srgbClr val="BED3E5"/>
+                      </a:solidFill>
+                    </a:lnB>
+                    <a:solidFill>
+                      <a:srgbClr val="FFFFFF"/>
+                    </a:solidFill>
+                  </a:tcPr>
+                </a:tc>
+              </a:tr>
+              <a:tr h="365760">
+                <a:tc>
+                  <a:txBody>
+                    <a:bodyPr/>
+                    <a:lstStyle/>
+                    <a:p>
+                      <a:pPr algn="l"/>
+                      <a:r>
+                        <a:rPr sz="1600" b="0" i="0">
+                          <a:solidFill>
+                            <a:srgbClr val="12283D"/>
+                          </a:solidFill>
+                          <a:latin typeface="Arial"/>
+                        </a:rPr>
+                        <a:t>Hybrid kNN</a:t>
+                      </a:r>
+                    </a:p>
+                  </a:txBody>
+                  <a:tcPr marL="73152" marR="73152" marT="18288" marB="18288" anchor="ctr">
+                    <a:lnL w="9525">
+                      <a:solidFill>
+                        <a:srgbClr val="BED3E5"/>
+                      </a:solidFill>
+                    </a:lnL>
+                    <a:lnR w="9525">
+                      <a:solidFill>
+                        <a:srgbClr val="BED3E5"/>
+                      </a:solidFill>
+                    </a:lnR>
+                    <a:lnT w="9525">
+                      <a:solidFill>
+                        <a:srgbClr val="BED3E5"/>
+                      </a:solidFill>
+                    </a:lnT>
+                    <a:lnB w="9525">
+                      <a:solidFill>
+                        <a:srgbClr val="BED3E5"/>
+                      </a:solidFill>
+                    </a:lnB>
+                    <a:solidFill>
+                      <a:srgbClr val="FFFFFF"/>
+                    </a:solidFill>
+                  </a:tcPr>
+                </a:tc>
+                <a:tc>
+                  <a:txBody>
+                    <a:bodyPr/>
+                    <a:lstStyle/>
+                    <a:p>
+                      <a:pPr algn="ctr"/>
+                      <a:r>
+                        <a:rPr sz="1600" b="0" i="0">
+                          <a:solidFill>
+                            <a:srgbClr val="12283D"/>
+                          </a:solidFill>
+                          <a:latin typeface="Arial"/>
+                        </a:rPr>
+                        <a:t>new</a:t>
+                      </a:r>
+                    </a:p>
+                  </a:txBody>
+                  <a:tcPr marL="73152" marR="73152" marT="18288" marB="18288" anchor="ctr">
+                    <a:lnL w="9525">
+                      <a:solidFill>
+                        <a:srgbClr val="BED3E5"/>
+                      </a:solidFill>
+                    </a:lnL>
+                    <a:lnR w="9525">
+                      <a:solidFill>
+                        <a:srgbClr val="BED3E5"/>
+                      </a:solidFill>
+                    </a:lnR>
+                    <a:lnT w="9525">
+                      <a:solidFill>
+                        <a:srgbClr val="BED3E5"/>
+                      </a:solidFill>
+                    </a:lnT>
+                    <a:lnB w="9525">
+                      <a:solidFill>
+                        <a:srgbClr val="BED3E5"/>
+                      </a:solidFill>
+                    </a:lnB>
+                    <a:solidFill>
+                      <a:srgbClr val="FFFFFF"/>
+                    </a:solidFill>
+                  </a:tcPr>
+                </a:tc>
+                <a:tc>
+                  <a:txBody>
+                    <a:bodyPr/>
+                    <a:lstStyle/>
+                    <a:p>
+                      <a:pPr algn="ctr"/>
+                      <a:r>
+                        <a:rPr sz="1600" b="0" i="0">
+                          <a:solidFill>
+                            <a:srgbClr val="12283D"/>
+                          </a:solidFill>
+                          <a:latin typeface="Arial"/>
+                        </a:rPr>
+                        <a:t>TF-IDF + multilingual-e5-base, reciprocal rank fusion</a:t>
+                      </a:r>
+                    </a:p>
+                  </a:txBody>
+                  <a:tcPr marL="73152" marR="73152" marT="18288" marB="18288" anchor="ctr">
+                    <a:lnL w="9525">
+                      <a:solidFill>
+                        <a:srgbClr val="BED3E5"/>
+                      </a:solidFill>
+                    </a:lnL>
+                    <a:lnR w="9525">
+                      <a:solidFill>
+                        <a:srgbClr val="BED3E5"/>
+                      </a:solidFill>
+                    </a:lnR>
+                    <a:lnT w="9525">
+                      <a:solidFill>
+                        <a:srgbClr val="BED3E5"/>
+                      </a:solidFill>
+                    </a:lnT>
+                    <a:lnB w="9525">
+                      <a:solidFill>
+                        <a:srgbClr val="BED3E5"/>
+                      </a:solidFill>
+                    </a:lnB>
+                    <a:solidFill>
+                      <a:srgbClr val="FFFFFF"/>
+                    </a:solidFill>
+                  </a:tcPr>
+                </a:tc>
+              </a:tr>
+              <a:tr h="365760">
+                <a:tc>
+                  <a:txBody>
+                    <a:bodyPr/>
+                    <a:lstStyle/>
+                    <a:p>
+                      <a:pPr algn="l"/>
+                      <a:r>
+                        <a:rPr sz="1600" b="0" i="0">
+                          <a:solidFill>
+                            <a:srgbClr val="12283D"/>
+                          </a:solidFill>
+                          <a:latin typeface="Arial"/>
+                        </a:rPr>
+                        <a:t>NALTRA votes</a:t>
+                      </a:r>
+                    </a:p>
+                  </a:txBody>
+                  <a:tcPr marL="73152" marR="73152" marT="18288" marB="18288" anchor="ctr">
+                    <a:lnL w="9525">
+                      <a:solidFill>
+                        <a:srgbClr val="BED3E5"/>
+                      </a:solidFill>
+                    </a:lnL>
+                    <a:lnR w="9525">
+                      <a:solidFill>
+                        <a:srgbClr val="BED3E5"/>
+                      </a:solidFill>
+                    </a:lnR>
+                    <a:lnT w="9525">
+                      <a:solidFill>
+                        <a:srgbClr val="BED3E5"/>
+                      </a:solidFill>
+                    </a:lnT>
+                    <a:lnB w="9525">
+                      <a:solidFill>
+                        <a:srgbClr val="BED3E5"/>
+                      </a:solidFill>
+                    </a:lnB>
+                    <a:solidFill>
+                      <a:srgbClr val="FFFFFF"/>
+                    </a:solidFill>
+                  </a:tcPr>
+                </a:tc>
+                <a:tc>
+                  <a:txBody>
+                    <a:bodyPr/>
+                    <a:lstStyle/>
+                    <a:p>
+                      <a:pPr algn="ctr"/>
+                      <a:r>
+                        <a:rPr sz="1600" b="0" i="0">
+                          <a:solidFill>
+                            <a:srgbClr val="12283D"/>
+                          </a:solidFill>
+                          <a:latin typeface="Arial"/>
+                        </a:rPr>
+                        <a:t>new</a:t>
+                      </a:r>
+                    </a:p>
+                  </a:txBody>
+                  <a:tcPr marL="73152" marR="73152" marT="18288" marB="18288" anchor="ctr">
+                    <a:lnL w="9525">
+                      <a:solidFill>
+                        <a:srgbClr val="BED3E5"/>
+                      </a:solidFill>
+                    </a:lnL>
+                    <a:lnR w="9525">
+                      <a:solidFill>
+                        <a:srgbClr val="BED3E5"/>
+                      </a:solidFill>
+                    </a:lnR>
+                    <a:lnT w="9525">
+                      <a:solidFill>
+                        <a:srgbClr val="BED3E5"/>
+                      </a:solidFill>
+                    </a:lnT>
+                    <a:lnB w="9525">
+                      <a:solidFill>
+                        <a:srgbClr val="BED3E5"/>
+                      </a:solidFill>
+                    </a:lnB>
+                    <a:solidFill>
+                      <a:srgbClr val="FFFFFF"/>
+                    </a:solidFill>
+                  </a:tcPr>
+                </a:tc>
+                <a:tc>
+                  <a:txBody>
+                    <a:bodyPr/>
+                    <a:lstStyle/>
+                    <a:p>
+                      <a:pPr algn="ctr"/>
+                      <a:r>
+                        <a:rPr sz="1600" b="0" i="0">
+                          <a:solidFill>
+                            <a:srgbClr val="12283D"/>
+                          </a:solidFill>
+                          <a:latin typeface="Arial"/>
+                        </a:rPr>
+                        <a:t>Hard/soft votes: SVM, kNN, BiLSTM, XLM-R (+ Kev, Jev on sample)</a:t>
+                      </a:r>
+                    </a:p>
+                  </a:txBody>
+                  <a:tcPr marL="73152" marR="73152" marT="18288" marB="18288" anchor="ctr">
+                    <a:lnL w="9525">
+                      <a:solidFill>
+                        <a:srgbClr val="BED3E5"/>
+                      </a:solidFill>
+                    </a:lnL>
+                    <a:lnR w="9525">
+                      <a:solidFill>
+                        <a:srgbClr val="BED3E5"/>
+                      </a:solidFill>
+                    </a:lnR>
+                    <a:lnT w="9525">
+                      <a:solidFill>
+                        <a:srgbClr val="BED3E5"/>
+                      </a:solidFill>
+                    </a:lnT>
+                    <a:lnB w="9525">
+                      <a:solidFill>
+                        <a:srgbClr val="BED3E5"/>
+                      </a:solidFill>
+                    </a:lnB>
+                    <a:solidFill>
+                      <a:srgbClr val="FFFFFF"/>
+                    </a:solidFill>
+                  </a:tcPr>
+                </a:tc>
+              </a:tr>
+              <a:tr h="365760">
+                <a:tc>
+                  <a:txBody>
+                    <a:bodyPr/>
+                    <a:lstStyle/>
+                    <a:p>
+                      <a:pPr algn="l"/>
+                      <a:r>
+                        <a:rPr sz="1600" b="0" i="0">
+                          <a:solidFill>
+                            <a:srgbClr val="12283D"/>
+                          </a:solidFill>
+                          <a:latin typeface="Arial"/>
+                        </a:rPr>
+                        <a:t>Kev</a:t>
+                      </a:r>
+                    </a:p>
+                  </a:txBody>
+                  <a:tcPr marL="73152" marR="73152" marT="18288" marB="18288" anchor="ctr">
+                    <a:lnL w="9525">
+                      <a:solidFill>
+                        <a:srgbClr val="BED3E5"/>
+                      </a:solidFill>
+                    </a:lnL>
+                    <a:lnR w="9525">
+                      <a:solidFill>
+                        <a:srgbClr val="BED3E5"/>
+                      </a:solidFill>
+                    </a:lnR>
+                    <a:lnT w="9525">
+                      <a:solidFill>
+                        <a:srgbClr val="BED3E5"/>
+                      </a:solidFill>
+                    </a:lnT>
+                    <a:lnB w="9525">
+                      <a:solidFill>
+                        <a:srgbClr val="BED3E5"/>
+                      </a:solidFill>
+                    </a:lnB>
+                    <a:solidFill>
+                      <a:srgbClr val="FFFFFF"/>
+                    </a:solidFill>
+                  </a:tcPr>
+                </a:tc>
+                <a:tc>
+                  <a:txBody>
+                    <a:bodyPr/>
+                    <a:lstStyle/>
+                    <a:p>
+                      <a:pPr algn="ctr"/>
+                      <a:r>
+                        <a:rPr sz="1600" b="0" i="0">
+                          <a:solidFill>
+                            <a:srgbClr val="12283D"/>
+                          </a:solidFill>
+                          <a:latin typeface="Arial"/>
+                        </a:rPr>
+                        <a:t>new</a:t>
+                      </a:r>
+                    </a:p>
+                  </a:txBody>
+                  <a:tcPr marL="73152" marR="73152" marT="18288" marB="18288" anchor="ctr">
+                    <a:lnL w="9525">
+                      <a:solidFill>
+                        <a:srgbClr val="BED3E5"/>
+                      </a:solidFill>
+                    </a:lnL>
+                    <a:lnR w="9525">
+                      <a:solidFill>
+                        <a:srgbClr val="BED3E5"/>
+                      </a:solidFill>
+                    </a:lnR>
+                    <a:lnT w="9525">
+                      <a:solidFill>
+                        <a:srgbClr val="BED3E5"/>
+                      </a:solidFill>
+                    </a:lnT>
+                    <a:lnB w="9525">
+                      <a:solidFill>
+                        <a:srgbClr val="BED3E5"/>
+                      </a:solidFill>
+                    </a:lnB>
+                    <a:solidFill>
+                      <a:srgbClr val="FFFFFF"/>
+                    </a:solidFill>
+                  </a:tcPr>
+                </a:tc>
+                <a:tc>
+                  <a:txBody>
+                    <a:bodyPr/>
+                    <a:lstStyle/>
+                    <a:p>
+                      <a:pPr algn="ctr"/>
+                      <a:r>
+                        <a:rPr sz="1600" b="0" i="0">
+                          <a:solidFill>
+                            <a:srgbClr val="12283D"/>
+                          </a:solidFill>
+                          <a:latin typeface="Arial"/>
+                        </a:rPr>
+                        <a:t>Kev-0.8B, local zero-shot yes/no per label</a:t>
+                      </a:r>
+                    </a:p>
+                  </a:txBody>
+                  <a:tcPr marL="73152" marR="73152" marT="18288" marB="18288" anchor="ctr">
+                    <a:lnL w="9525">
+                      <a:solidFill>
+                        <a:srgbClr val="BED3E5"/>
+                      </a:solidFill>
+                    </a:lnL>
+                    <a:lnR w="9525">
+                      <a:solidFill>
+                        <a:srgbClr val="BED3E5"/>
+                      </a:solidFill>
+                    </a:lnR>
+                    <a:lnT w="9525">
+                      <a:solidFill>
+                        <a:srgbClr val="BED3E5"/>
+                      </a:solidFill>
+                    </a:lnT>
+                    <a:lnB w="9525">
+                      <a:solidFill>
+                        <a:srgbClr val="BED3E5"/>
+                      </a:solidFill>
+                    </a:lnB>
+                    <a:solidFill>
+                      <a:srgbClr val="FFFFFF"/>
+                    </a:solidFill>
+                  </a:tcPr>
+                </a:tc>
+              </a:tr>
+              <a:tr h="365760">
+                <a:tc>
+                  <a:txBody>
+                    <a:bodyPr/>
+                    <a:lstStyle/>
+                    <a:p>
+                      <a:pPr algn="l"/>
+                      <a:r>
+                        <a:rPr sz="1600" b="0" i="0">
+                          <a:solidFill>
+                            <a:srgbClr val="12283D"/>
+                          </a:solidFill>
+                          <a:latin typeface="Arial"/>
+                        </a:rPr>
+                        <a:t>Jev</a:t>
+                      </a:r>
+                    </a:p>
+                  </a:txBody>
+                  <a:tcPr marL="73152" marR="73152" marT="18288" marB="18288" anchor="ctr">
+                    <a:lnL w="9525">
+                      <a:solidFill>
+                        <a:srgbClr val="BED3E5"/>
+                      </a:solidFill>
+                    </a:lnL>
+                    <a:lnR w="9525">
+                      <a:solidFill>
+                        <a:srgbClr val="BED3E5"/>
+                      </a:solidFill>
+                    </a:lnR>
+                    <a:lnT w="9525">
+                      <a:solidFill>
+                        <a:srgbClr val="BED3E5"/>
+                      </a:solidFill>
+                    </a:lnT>
+                    <a:lnB w="9525">
+                      <a:solidFill>
+                        <a:srgbClr val="BED3E5"/>
+                      </a:solidFill>
+                    </a:lnB>
+                    <a:solidFill>
+                      <a:srgbClr val="FFFFFF"/>
+                    </a:solidFill>
+                  </a:tcPr>
+                </a:tc>
+                <a:tc>
+                  <a:txBody>
+                    <a:bodyPr/>
+                    <a:lstStyle/>
+                    <a:p>
+                      <a:pPr algn="ctr"/>
+                      <a:r>
+                        <a:rPr sz="1600" b="0" i="0">
+                          <a:solidFill>
+                            <a:srgbClr val="12283D"/>
+                          </a:solidFill>
+                          <a:latin typeface="Arial"/>
+                        </a:rPr>
+                        <a:t>new</a:t>
+                      </a:r>
+                    </a:p>
+                  </a:txBody>
+                  <a:tcPr marL="73152" marR="73152" marT="18288" marB="18288" anchor="ctr">
+                    <a:lnL w="9525">
+                      <a:solidFill>
+                        <a:srgbClr val="BED3E5"/>
+                      </a:solidFill>
+                    </a:lnL>
+                    <a:lnR w="9525">
+                      <a:solidFill>
+                        <a:srgbClr val="BED3E5"/>
+                      </a:solidFill>
+                    </a:lnR>
+                    <a:lnT w="9525">
+                      <a:solidFill>
+                        <a:srgbClr val="BED3E5"/>
+                      </a:solidFill>
+                    </a:lnT>
+                    <a:lnB w="9525">
+                      <a:solidFill>
+                        <a:srgbClr val="BED3E5"/>
+                      </a:solidFill>
+                    </a:lnB>
+                    <a:solidFill>
+                      <a:srgbClr val="FFFFFF"/>
+                    </a:solidFill>
+                  </a:tcPr>
+                </a:tc>
+                <a:tc>
+                  <a:txBody>
+                    <a:bodyPr/>
+                    <a:lstStyle/>
+                    <a:p>
+                      <a:pPr algn="ctr"/>
+                      <a:r>
+                        <a:rPr sz="1600" b="0" i="0">
+                          <a:solidFill>
+                            <a:srgbClr val="12283D"/>
+                          </a:solidFill>
+                          <a:latin typeface="Arial"/>
+                        </a:rPr>
+                        <a:t>Hosted zero-shot yes/no per label</a:t>
+                      </a:r>
+                    </a:p>
+                  </a:txBody>
+                  <a:tcPr marL="73152" marR="73152" marT="18288" marB="18288" anchor="ctr">
+                    <a:lnL w="9525">
+                      <a:solidFill>
+                        <a:srgbClr val="BED3E5"/>
+                      </a:solidFill>
+                    </a:lnL>
+                    <a:lnR w="9525">
+                      <a:solidFill>
+                        <a:srgbClr val="BED3E5"/>
+                      </a:solidFill>
+                    </a:lnR>
+                    <a:lnT w="9525">
+                      <a:solidFill>
+                        <a:srgbClr val="BED3E5"/>
+                      </a:solidFill>
+                    </a:lnT>
+                    <a:lnB w="9525">
+                      <a:solidFill>
+                        <a:srgbClr val="BED3E5"/>
+                      </a:solidFill>
+                    </a:lnB>
+                    <a:solidFill>
+                      <a:srgbClr val="FFFFFF"/>
+                    </a:solidFill>
+                  </a:tcPr>
+                </a:tc>
+              </a:tr>
+              <a:tr h="365760">
+                <a:tc>
+                  <a:txBody>
+                    <a:bodyPr/>
+                    <a:lstStyle/>
+                    <a:p>
+                      <a:pPr algn="l"/>
+                      <a:r>
+                        <a:rPr sz="1600" b="0" i="0">
+                          <a:solidFill>
+                            <a:srgbClr val="12283D"/>
+                          </a:solidFill>
+                          <a:latin typeface="Arial"/>
+                        </a:rPr>
+                        <a:t>Laya</a:t>
+                      </a:r>
+                    </a:p>
+                  </a:txBody>
+                  <a:tcPr marL="73152" marR="73152" marT="18288" marB="18288" anchor="ctr">
+                    <a:lnL w="9525">
+                      <a:solidFill>
+                        <a:srgbClr val="BED3E5"/>
+                      </a:solidFill>
+                    </a:lnL>
+                    <a:lnR w="9525">
+                      <a:solidFill>
+                        <a:srgbClr val="BED3E5"/>
+                      </a:solidFill>
+                    </a:lnR>
+                    <a:lnT w="9525">
+                      <a:solidFill>
+                        <a:srgbClr val="BED3E5"/>
+                      </a:solidFill>
+                    </a:lnT>
+                    <a:lnB w="9525">
+                      <a:solidFill>
+                        <a:srgbClr val="BED3E5"/>
+                      </a:solidFill>
+                    </a:lnB>
+                    <a:solidFill>
+                      <a:srgbClr val="FFFFFF"/>
+                    </a:solidFill>
+                  </a:tcPr>
+                </a:tc>
+                <a:tc>
+                  <a:txBody>
+                    <a:bodyPr/>
+                    <a:lstStyle/>
+                    <a:p>
+                      <a:pPr algn="ctr"/>
+                      <a:r>
+                        <a:rPr sz="1600" b="0" i="0">
+                          <a:solidFill>
+                            <a:srgbClr val="12283D"/>
+                          </a:solidFill>
+                          <a:latin typeface="Arial"/>
+                        </a:rPr>
+                        <a:t>new</a:t>
+                      </a:r>
+                    </a:p>
+                  </a:txBody>
+                  <a:tcPr marL="73152" marR="73152" marT="18288" marB="18288" anchor="ctr">
+                    <a:lnL w="9525">
+                      <a:solidFill>
+                        <a:srgbClr val="BED3E5"/>
+                      </a:solidFill>
+                    </a:lnL>
+                    <a:lnR w="9525">
+                      <a:solidFill>
+                        <a:srgbClr val="BED3E5"/>
+                      </a:solidFill>
+                    </a:lnR>
+                    <a:lnT w="9525">
+                      <a:solidFill>
+                        <a:srgbClr val="BED3E5"/>
+                      </a:solidFill>
+                    </a:lnT>
+                    <a:lnB w="9525">
+                      <a:solidFill>
+                        <a:srgbClr val="BED3E5"/>
+                      </a:solidFill>
+                    </a:lnB>
+                    <a:solidFill>
+                      <a:srgbClr val="FFFFFF"/>
+                    </a:solidFill>
+                  </a:tcPr>
+                </a:tc>
+                <a:tc>
+                  <a:txBody>
+                    <a:bodyPr/>
+                    <a:lstStyle/>
+                    <a:p>
+                      <a:pPr algn="ctr"/>
+                      <a:r>
+                        <a:rPr sz="1600" b="0" i="0">
+                          <a:solidFill>
+                            <a:srgbClr val="12283D"/>
+                          </a:solidFill>
+                          <a:latin typeface="Arial"/>
+                        </a:rPr>
+                        <a:t>convaiinnovations/laya, zero-shot choice; scored, no vote</a:t>
+                      </a:r>
+                    </a:p>
+                  </a:txBody>
+                  <a:tcPr marL="73152" marR="73152" marT="18288" marB="18288" anchor="ctr">
+                    <a:lnL w="9525">
+                      <a:solidFill>
+                        <a:srgbClr val="BED3E5"/>
+                      </a:solidFill>
+                    </a:lnL>
+                    <a:lnR w="9525">
+                      <a:solidFill>
+                        <a:srgbClr val="BED3E5"/>
+                      </a:solidFill>
+                    </a:lnR>
+                    <a:lnT w="9525">
+                      <a:solidFill>
+                        <a:srgbClr val="BED3E5"/>
+                      </a:solidFill>
+                    </a:lnT>
+                    <a:lnB w="9525">
+                      <a:solidFill>
+                        <a:srgbClr val="BED3E5"/>
+                      </a:solidFill>
+                    </a:lnB>
+                    <a:solidFill>
+                      <a:srgbClr val="FFFFFF"/>
+                    </a:solidFill>
+                  </a:tcPr>
+                </a:tc>
+              </a:tr>
+            </a:tbl>
+          </a:graphicData>
+        </a:graphic>
+      </p:graphicFrame>
+      <p:sp>
+        <p:nvSpPr>
+          <p:cNvPr id="6" name="TextBox 5"/>
+          <p:cNvSpPr txBox="1"/>
+          <p:nvPr/>
+        </p:nvSpPr>
+        <p:spPr>
+          <a:xfrm>
+            <a:off x="609904" y="5532120"/>
+            <a:ext cx="10972800" cy="640080"/>
+          </a:xfrm>
+          <a:prstGeom prst="rect">
+            <a:avLst/>
+          </a:prstGeom>
+          <a:noFill/>
+        </p:spPr>
+        <p:txBody>
+          <a:bodyPr wrap="square" anchor="t" lIns="0" rIns="0" tIns="0" bIns="0">
+            <a:noAutofit/>
+          </a:bodyPr>
+          <a:lstStyle/>
+          <a:p>
+            <a:pPr algn="l">
+              <a:spcAft>
+                <a:spcPts val="200"/>
+              </a:spcAft>
+            </a:pPr>
+            <a:r>
+              <a:rPr sz="1600" b="0" i="0">
+                <a:solidFill>
+                  <a:srgbClr val="516170"/>
+                </a:solidFill>
+                <a:latin typeface="Arial"/>
+              </a:rPr>
+              <a:t>Trained members see English and machine-translated Turkish; Kev, Jev and Laya are not fine-tuned on CORDIS.</a:t>
+            </a:r>
+          </a:p>
+          <a:p>
+            <a:pPr algn="l">
+              <a:spcAft>
+                <a:spcPts val="200"/>
+              </a:spcAft>
+            </a:pPr>
+            <a:r>
+              <a:rPr sz="1600" b="0" i="0">
+                <a:solidFill>
+                  <a:srgbClr val="516170"/>
+                </a:solidFill>
+                <a:latin typeface="Arial"/>
+              </a:rPr>
+              <a:t>Roles: configs/benchmark.yaml · settings: configs/models/*.yaml</a:t>
             </a:r>
           </a:p>
         </p:txBody>

</xml_diff>